<commit_message>
fix: import reports on defectdojo
</commit_message>
<xml_diff>
--- a/appsec-palestra.pptx
+++ b/appsec-palestra.pptx
@@ -17713,7 +17713,7 @@
                 </a:solidFill>
                 <a:latin typeface="Segoe UI"/>
               </a:rPr>
-              <a:t>Severe Underweight</a:t>
+              <a:t>Magreza grave</a:t>
             </a:r>
           </a:p>
         </p:txBody>
@@ -17869,7 +17869,7 @@
                 </a:solidFill>
                 <a:latin typeface="Segoe UI"/>
               </a:rPr>
-              <a:t>Underweight</a:t>
+              <a:t>Abaixo do peso</a:t>
             </a:r>
           </a:p>
         </p:txBody>
@@ -18025,7 +18025,7 @@
                 </a:solidFill>
                 <a:latin typeface="Segoe UI"/>
               </a:rPr>
-              <a:t>Normal weight</a:t>
+              <a:t>Peso normal</a:t>
             </a:r>
           </a:p>
         </p:txBody>
@@ -18181,7 +18181,7 @@
                 </a:solidFill>
                 <a:latin typeface="Segoe UI"/>
               </a:rPr>
-              <a:t>Overweight</a:t>
+              <a:t>Sobrepeso</a:t>
             </a:r>
           </a:p>
         </p:txBody>
@@ -18337,7 +18337,7 @@
                 </a:solidFill>
                 <a:latin typeface="Segoe UI"/>
               </a:rPr>
-              <a:t>Obesity Class I</a:t>
+              <a:t>Obesidade grau I</a:t>
             </a:r>
           </a:p>
         </p:txBody>
@@ -18493,7 +18493,7 @@
                 </a:solidFill>
                 <a:latin typeface="Segoe UI"/>
               </a:rPr>
-              <a:t>Obesity Class II</a:t>
+              <a:t>Obesidade grau II</a:t>
             </a:r>
           </a:p>
         </p:txBody>
@@ -18649,7 +18649,7 @@
                 </a:solidFill>
                 <a:latin typeface="Segoe UI"/>
               </a:rPr>
-              <a:t>Obesity Class III</a:t>
+              <a:t>Obesidade grau III</a:t>
             </a:r>
           </a:p>
         </p:txBody>

</xml_diff>